<commit_message>
Start Step 7: live market data validation
Pulls a live SPY options chain via yfinance and compares real implied
volatility against our synthetic Heston skew -- confirms the same
downward skew direction, with an honest caveat about expiry mismatch.
Also attempts NSE India's option chain as a documented, known-fragile
fallback (currently blocked by their bot detection).

Updates slides and progress notes to reflect Step 7 now underway.

Co-Authored-By: Claude Sonnet 5 <noreply@anthropic.com>
</commit_message>
<xml_diff>
--- a/slides/Review2_ProgressUpdate.pptx
+++ b/slides/Review2_ProgressUpdate.pptx
@@ -14,9 +14,10 @@
     <p:sldId id="262" r:id="rId8"/>
     <p:sldId id="263" r:id="rId9"/>
     <p:sldId id="264" r:id="rId10"/>
+    <p:sldId id="265" r:id="rId11"/>
   </p:sldIdLst>
   <p:notesMasterIdLst>
-    <p:notesMasterId r:id="rId11"/>
+    <p:notesMasterId r:id="rId12"/>
   </p:notesMasterIdLst>
   <p:sldSz cx="12192000" cy="6858000"/>
   <p:notesSz cx="6858000" cy="12192000"/>
@@ -534,6 +535,94 @@
             <a:fld id="{F7021451-1387-4CA6-816F-3879F97B5CBC}" type="slidenum">
               <a:rPr lang="en-US"/>
               <a:t>1</a:t>
+            </a:fld>
+            <a:endParaRPr lang="en-US"/>
+          </a:p>
+        </p:txBody>
+      </p:sp>
+    </p:spTree>
+    <p:extLst>
+      <p:ext uri="{BB962C8B-B14F-4D97-AF65-F5344CB8AC3E}">
+        <p14:creationId xmlns:p14="http://schemas.microsoft.com/office/powerpoint/2010/main" val="1024086991"/>
+      </p:ext>
+    </p:extLst>
+  </p:cSld>
+  <p:clrMapOvr>
+    <a:masterClrMapping/>
+  </p:clrMapOvr>
+</p:notes>
+</file>
+
+<file path=ppt/notesSlides/notesSlide10.xml><?xml version="1.0" encoding="utf-8"?>
+<p:notes xmlns:a="http://schemas.openxmlformats.org/drawingml/2006/main" xmlns:r="http://schemas.openxmlformats.org/officeDocument/2006/relationships" xmlns:p="http://schemas.openxmlformats.org/presentationml/2006/main">
+  <p:cSld>
+    <p:spTree>
+      <p:nvGrpSpPr>
+        <p:cNvPr id="1" name=""/>
+        <p:cNvGrpSpPr/>
+        <p:nvPr/>
+      </p:nvGrpSpPr>
+      <p:grpSpPr>
+        <a:xfrm>
+          <a:off x="0" y="0"/>
+          <a:ext cx="0" cy="0"/>
+          <a:chOff x="0" y="0"/>
+          <a:chExt cx="0" cy="0"/>
+        </a:xfrm>
+      </p:grpSpPr>
+      <p:sp>
+        <p:nvSpPr>
+          <p:cNvPr id="2" name="Slide Image Placeholder 1"/>
+          <p:cNvSpPr>
+            <a:spLocks noGrp="1" noRot="1" noChangeAspect="1"/>
+          </p:cNvSpPr>
+          <p:nvPr>
+            <p:ph type="sldImg"/>
+          </p:nvPr>
+        </p:nvSpPr>
+        <p:spPr/>
+      </p:sp>
+      <p:sp>
+        <p:nvSpPr>
+          <p:cNvPr id="3" name="Notes Placeholder 2"/>
+          <p:cNvSpPr>
+            <a:spLocks noGrp="1"/>
+          </p:cNvSpPr>
+          <p:nvPr>
+            <p:ph type="body" idx="1"/>
+          </p:nvPr>
+        </p:nvSpPr>
+        <p:spPr/>
+        <p:txBody>
+          <a:bodyPr/>
+          <a:lstStyle/>
+          <a:p>
+            <a:r>
+              <a:rPr lang="en-US" dirty="0"/>
+              <a:t/>
+            </a:r>
+            <a:endParaRPr lang="en-US" dirty="0"/>
+          </a:p>
+        </p:txBody>
+      </p:sp>
+      <p:sp>
+        <p:nvSpPr>
+          <p:cNvPr id="4" name="Slide Number Placeholder 3"/>
+          <p:cNvSpPr>
+            <a:spLocks noGrp="1"/>
+          </p:cNvSpPr>
+          <p:nvPr>
+            <p:ph type="sldNum" sz="quarter" idx="10"/>
+          </p:nvPr>
+        </p:nvSpPr>
+        <p:spPr/>
+        <p:txBody>
+          <a:bodyPr/>
+          <a:lstStyle/>
+          <a:p>
+            <a:fld id="{F7021451-1387-4CA6-816F-3879F97B5CBC}" type="slidenum">
+              <a:rPr lang="en-US"/>
+              <a:t>10</a:t>
             </a:fld>
             <a:endParaRPr lang="en-US"/>
           </a:p>
@@ -2249,6 +2338,248 @@
 </p:sld>
 </file>
 
+<file path=ppt/slides/slide10.xml><?xml version="1.0" encoding="utf-8"?>
+<p:sld xmlns:a="http://schemas.openxmlformats.org/drawingml/2006/main" xmlns:r="http://schemas.openxmlformats.org/officeDocument/2006/relationships" xmlns:p="http://schemas.openxmlformats.org/presentationml/2006/main">
+  <p:cSld name="Slide 10">
+    <p:spTree>
+      <p:nvGrpSpPr>
+        <p:cNvPr id="1" name=""/>
+        <p:cNvGrpSpPr/>
+        <p:nvPr/>
+      </p:nvGrpSpPr>
+      <p:grpSpPr>
+        <a:xfrm>
+          <a:off x="0" y="0"/>
+          <a:ext cx="0" cy="0"/>
+          <a:chOff x="0" y="0"/>
+          <a:chExt cx="0" cy="0"/>
+        </a:xfrm>
+      </p:grpSpPr>
+      <p:sp>
+        <p:nvSpPr>
+          <p:cNvPr id="2" name="Shape 0"/>
+          <p:cNvSpPr/>
+          <p:nvPr/>
+        </p:nvSpPr>
+        <p:spPr>
+          <a:xfrm>
+            <a:off x="9646920" y="4206240"/>
+            <a:ext cx="2011680" cy="2011680"/>
+          </a:xfrm>
+          <a:prstGeom prst="ellipse">
+            <a:avLst/>
+          </a:prstGeom>
+          <a:solidFill>
+            <a:srgbClr val="2A3570"/>
+          </a:solidFill>
+          <a:ln/>
+        </p:spPr>
+      </p:sp>
+      <p:sp>
+        <p:nvSpPr>
+          <p:cNvPr id="3" name="Shape 1"/>
+          <p:cNvSpPr/>
+          <p:nvPr/>
+        </p:nvSpPr>
+        <p:spPr>
+          <a:xfrm>
+            <a:off x="10012680" y="4572000"/>
+            <a:ext cx="1280160" cy="1280160"/>
+          </a:xfrm>
+          <a:prstGeom prst="ellipse">
+            <a:avLst/>
+          </a:prstGeom>
+          <a:solidFill>
+            <a:srgbClr val="C9A227"/>
+          </a:solidFill>
+          <a:ln/>
+        </p:spPr>
+      </p:sp>
+      <p:sp>
+        <p:nvSpPr>
+          <p:cNvPr id="4" name="Text 2"/>
+          <p:cNvSpPr txBox="1"/>
+          <p:nvPr/>
+        </p:nvSpPr>
+        <p:spPr>
+          <a:xfrm>
+            <a:off x="731520" y="2377440"/>
+            <a:ext cx="7315200" cy="1005840"/>
+          </a:xfrm>
+          <a:prstGeom prst="rect">
+            <a:avLst/>
+          </a:prstGeom>
+          <a:noFill/>
+          <a:ln/>
+        </p:spPr>
+        <p:txBody>
+          <a:bodyPr wrap="square" lIns="0" tIns="0" rIns="0" bIns="0" rtlCol="0" anchor="ctr"/>
+          <a:lstStyle/>
+          <a:p>
+            <a:pPr indent="0" marL="0">
+              <a:buNone/>
+            </a:pPr>
+            <a:r>
+              <a:rPr lang="en-US" sz="4400" b="1" dirty="0">
+                <a:solidFill>
+                  <a:srgbClr val="FFFFFF"/>
+                </a:solidFill>
+                <a:latin typeface="Cambria" pitchFamily="34" charset="0"/>
+                <a:ea typeface="Cambria" pitchFamily="34" charset="-122"/>
+                <a:cs typeface="Cambria" pitchFamily="34" charset="-120"/>
+              </a:rPr>
+              <a:t>Thank You</a:t>
+            </a:r>
+            <a:endParaRPr lang="en-US" sz="4400" dirty="0"/>
+          </a:p>
+        </p:txBody>
+      </p:sp>
+      <p:sp>
+        <p:nvSpPr>
+          <p:cNvPr id="5" name="Text 3"/>
+          <p:cNvSpPr txBox="1"/>
+          <p:nvPr/>
+        </p:nvSpPr>
+        <p:spPr>
+          <a:xfrm>
+            <a:off x="731520" y="3429000"/>
+            <a:ext cx="7772400" cy="548640"/>
+          </a:xfrm>
+          <a:prstGeom prst="rect">
+            <a:avLst/>
+          </a:prstGeom>
+          <a:noFill/>
+          <a:ln/>
+        </p:spPr>
+        <p:txBody>
+          <a:bodyPr wrap="square" lIns="0" tIns="0" rIns="0" bIns="0" rtlCol="0" anchor="ctr"/>
+          <a:lstStyle/>
+          <a:p>
+            <a:pPr indent="0" marL="0">
+              <a:buNone/>
+            </a:pPr>
+            <a:r>
+              <a:rPr lang="en-US" sz="1600" dirty="0">
+                <a:solidFill>
+                  <a:srgbClr val="CADCFC"/>
+                </a:solidFill>
+                <a:latin typeface="Calibri" pitchFamily="34" charset="0"/>
+                <a:ea typeface="Calibri" pitchFamily="34" charset="-122"/>
+                <a:cs typeface="Calibri" pitchFamily="34" charset="-120"/>
+              </a:rPr>
+              <a:t>Questions welcome — code, data, and results are all open for review.</a:t>
+            </a:r>
+            <a:endParaRPr lang="en-US" sz="1600" dirty="0"/>
+          </a:p>
+        </p:txBody>
+      </p:sp>
+      <p:sp>
+        <p:nvSpPr>
+          <p:cNvPr id="6" name="Text 4"/>
+          <p:cNvSpPr txBox="1"/>
+          <p:nvPr/>
+        </p:nvSpPr>
+        <p:spPr>
+          <a:xfrm>
+            <a:off x="731520" y="5120640"/>
+            <a:ext cx="7315200" cy="365760"/>
+          </a:xfrm>
+          <a:prstGeom prst="rect">
+            <a:avLst/>
+          </a:prstGeom>
+          <a:noFill/>
+          <a:ln/>
+        </p:spPr>
+        <p:txBody>
+          <a:bodyPr wrap="square" lIns="0" tIns="0" rIns="0" bIns="0" rtlCol="0" anchor="ctr"/>
+          <a:lstStyle/>
+          <a:p>
+            <a:pPr indent="0" marL="0">
+              <a:buNone/>
+            </a:pPr>
+            <a:r>
+              <a:rPr lang="en-US" sz="1400" i="1" dirty="0">
+                <a:solidFill>
+                  <a:srgbClr val="C9A227"/>
+                </a:solidFill>
+                <a:latin typeface="Calibri" pitchFamily="34" charset="0"/>
+                <a:ea typeface="Calibri" pitchFamily="34" charset="-122"/>
+                <a:cs typeface="Calibri" pitchFamily="34" charset="-120"/>
+              </a:rPr>
+              <a:t>github.com/pastbologanesh0101/option-pricing-heston</a:t>
+            </a:r>
+            <a:endParaRPr lang="en-US" sz="1400" dirty="0"/>
+          </a:p>
+        </p:txBody>
+      </p:sp>
+      <p:sp>
+        <p:nvSpPr>
+          <p:cNvPr id="7" name="Text 0"/>
+          <p:cNvSpPr/>
+          <p:nvPr>
+            <p:ph idx="100" type="title" hasCustomPrompt="1"/>
+          </p:nvPr>
+        </p:nvSpPr>
+        <p:spPr>
+          <a:xfrm>
+            <a:off x="731520" y="2514600"/>
+            <a:ext cx="9326880" cy="1463040"/>
+          </a:xfrm>
+          <a:prstGeom prst="rect">
+            <a:avLst/>
+          </a:prstGeom>
+          <a:noFill/>
+          <a:ln/>
+        </p:spPr>
+        <p:txBody>
+          <a:bodyPr wrap="square" rtlCol="0" anchor="t"/>
+          <a:lstStyle/>
+          <a:p>
+            <a:pPr algn="l" indent="0" marL="0">
+              <a:buNone/>
+            </a:pPr>
+            <a:endParaRPr lang="en-US" sz="4000" dirty="0"/>
+          </a:p>
+        </p:txBody>
+      </p:sp>
+      <p:sp>
+        <p:nvSpPr>
+          <p:cNvPr id="8" name="Text 0"/>
+          <p:cNvSpPr/>
+          <p:nvPr>
+            <p:ph idx="101" type="body" hasCustomPrompt="1"/>
+          </p:nvPr>
+        </p:nvSpPr>
+        <p:spPr>
+          <a:xfrm>
+            <a:off x="731520" y="3977640"/>
+            <a:ext cx="9692640" cy="914400"/>
+          </a:xfrm>
+          <a:prstGeom prst="rect">
+            <a:avLst/>
+          </a:prstGeom>
+          <a:noFill/>
+          <a:ln/>
+        </p:spPr>
+        <p:txBody>
+          <a:bodyPr wrap="square" rtlCol="0" anchor="t"/>
+          <a:lstStyle/>
+          <a:p>
+            <a:pPr algn="l" indent="0" marL="0">
+              <a:buNone/>
+            </a:pPr>
+            <a:endParaRPr lang="en-US" sz="1600" dirty="0"/>
+          </a:p>
+        </p:txBody>
+      </p:sp>
+    </p:spTree>
+  </p:cSld>
+  <p:clrMapOvr>
+    <a:masterClrMapping/>
+  </p:clrMapOvr>
+</p:sld>
+</file>
+
 <file path=ppt/slides/slide2.xml><?xml version="1.0" encoding="utf-8"?>
 <p:sld xmlns:a="http://schemas.openxmlformats.org/drawingml/2006/main" xmlns:r="http://schemas.openxmlformats.org/officeDocument/2006/relationships" xmlns:p="http://schemas.openxmlformats.org/presentationml/2006/main">
   <p:cSld name="Slide 2">
@@ -3870,7 +4201,7 @@
             <a:avLst/>
           </a:prstGeom>
           <a:solidFill>
-            <a:srgbClr val="E3E6EE"/>
+            <a:srgbClr val="C9A227"/>
           </a:solidFill>
           <a:ln/>
         </p:spPr>
@@ -3902,7 +4233,7 @@
             <a:r>
               <a:rPr lang="en-US" sz="2400" b="1" dirty="0">
                 <a:solidFill>
-                  <a:srgbClr val="6B7280"/>
+                  <a:srgbClr val="FFFFFF"/>
                 </a:solidFill>
                 <a:latin typeface="Calibri" pitchFamily="34" charset="0"/>
                 <a:ea typeface="Calibri" pitchFamily="34" charset="-122"/>
@@ -3986,7 +4317,7 @@
                 <a:ea typeface="Calibri" pitchFamily="34" charset="-122"/>
                 <a:cs typeface="Calibri" pitchFamily="34" charset="-120"/>
               </a:rPr>
-              <a:t>Real market option data</a:t>
+              <a:t>Live market data pulled</a:t>
             </a:r>
             <a:endParaRPr lang="en-US" sz="1000" dirty="0"/>
           </a:p>
@@ -4349,17 +4680,17 @@
               <a:buNone/>
             </a:pPr>
             <a:r>
-              <a:rPr lang="en-US" sz="4000" b="1" dirty="0">
-                <a:solidFill>
-                  <a:srgbClr val="B5473A"/>
+              <a:rPr lang="en-US" sz="3600" b="1" dirty="0">
+                <a:solidFill>
+                  <a:srgbClr val="C9A227"/>
                 </a:solidFill>
                 <a:latin typeface="Cambria" pitchFamily="34" charset="0"/>
                 <a:ea typeface="Cambria" pitchFamily="34" charset="-122"/>
                 <a:cs typeface="Cambria" pitchFamily="34" charset="-120"/>
               </a:rPr>
-              <a:t>1</a:t>
-            </a:r>
-            <a:endParaRPr lang="en-US" sz="4000" dirty="0"/>
+              <a:t>LIVE</a:t>
+            </a:r>
+            <a:endParaRPr lang="en-US" sz="3600" dirty="0"/>
           </a:p>
         </p:txBody>
       </p:sp>
@@ -4396,7 +4727,7 @@
                 <a:ea typeface="Calibri" pitchFamily="34" charset="-122"/>
                 <a:cs typeface="Calibri" pitchFamily="34" charset="-120"/>
               </a:rPr>
-              <a:t>step remaining: real-data validation</a:t>
+              <a:t>step 7 underway: real SPY data pulled</a:t>
             </a:r>
             <a:endParaRPr lang="en-US" sz="1200" dirty="0"/>
           </a:p>
@@ -7348,51 +7679,85 @@
                 <a:ea typeface="Cambria" pitchFamily="34" charset="-122"/>
                 <a:cs typeface="Cambria" pitchFamily="34" charset="-120"/>
               </a:rPr>
-              <a:t>What's Left: Step 7</a:t>
+              <a:t>Step 7, Started: Real Market Data</a:t>
             </a:r>
             <a:endParaRPr lang="en-US" sz="3000" dirty="0"/>
           </a:p>
         </p:txBody>
       </p:sp>
-      <p:sp>
-        <p:nvSpPr>
-          <p:cNvPr id="3" name="Shape 1"/>
-          <p:cNvSpPr/>
+      <p:pic>
+        <p:nvPicPr>
+          <p:cNvPr id="3" name="Image 0" descr="/Users/vishwanathantamizharasan/option-pricing-heston/results/real_vs_synthetic_skew.png">    </p:cNvPr>
+          <p:cNvPicPr>
+            <a:picLocks noChangeAspect="1"/>
+          </p:cNvPicPr>
+          <p:nvPr/>
+        </p:nvPicPr>
+        <p:blipFill>
+          <a:blip r:embed="rId1"/>
+          <a:stretch>
+            <a:fillRect/>
+          </a:stretch>
+        </p:blipFill>
+        <p:spPr>
+          <a:xfrm>
+            <a:off x="6172200" y="1417320"/>
+            <a:ext cx="5486400" cy="3749040"/>
+          </a:xfrm>
+          <a:prstGeom prst="rect">
+            <a:avLst/>
+          </a:prstGeom>
+        </p:spPr>
+      </p:pic>
+      <p:sp>
+        <p:nvSpPr>
+          <p:cNvPr id="4" name="Text 1"/>
+          <p:cNvSpPr txBox="1"/>
+          <p:nvPr/>
+        </p:nvSpPr>
+        <p:spPr>
+          <a:xfrm>
+            <a:off x="6172200" y="5193792"/>
+            <a:ext cx="5486400" cy="457200"/>
+          </a:xfrm>
+          <a:prstGeom prst="rect">
+            <a:avLst/>
+          </a:prstGeom>
+          <a:noFill/>
+          <a:ln/>
+        </p:spPr>
+        <p:txBody>
+          <a:bodyPr wrap="square" lIns="0" tIns="0" rIns="0" bIns="0" rtlCol="0" anchor="ctr"/>
+          <a:lstStyle/>
+          <a:p>
+            <a:pPr indent="0" marL="0">
+              <a:buNone/>
+            </a:pPr>
+            <a:r>
+              <a:rPr lang="en-US" sz="1050" i="1" dirty="0">
+                <a:solidFill>
+                  <a:srgbClr val="6B7280"/>
+                </a:solidFill>
+                <a:latin typeface="Calibri" pitchFamily="34" charset="0"/>
+                <a:ea typeface="Calibri" pitchFamily="34" charset="-122"/>
+                <a:cs typeface="Calibri" pitchFamily="34" charset="-120"/>
+              </a:rPr>
+              <a:t>Live SPY options chain (yfinance), ~30 days to expiry, 123 liquid strikes — pulled minutes before this slide was built.</a:t>
+            </a:r>
+            <a:endParaRPr lang="en-US" sz="1050" dirty="0"/>
+          </a:p>
+        </p:txBody>
+      </p:sp>
+      <p:sp>
+        <p:nvSpPr>
+          <p:cNvPr id="5" name="Text 2"/>
+          <p:cNvSpPr txBox="1"/>
           <p:nvPr/>
         </p:nvSpPr>
         <p:spPr>
           <a:xfrm>
             <a:off x="548640" y="1463040"/>
-            <a:ext cx="5349240" cy="4572000"/>
-          </a:xfrm>
-          <a:prstGeom prst="roundRect">
-            <a:avLst>
-              <a:gd name="adj" fmla="val 1600"/>
-            </a:avLst>
-          </a:prstGeom>
-          <a:solidFill>
-            <a:srgbClr val="F0F1F7"/>
-          </a:solidFill>
-          <a:ln/>
-          <a:effectLst>
-            <a:outerShdw sx="100000" sy="100000" kx="0" ky="0" algn="bl" rotWithShape="0" blurRad="76200" dist="25400" dir="5400000">
-              <a:srgbClr val="000000">
-                <a:alpha val="12000"/>
-              </a:srgbClr>
-            </a:outerShdw>
-          </a:effectLst>
-        </p:spPr>
-      </p:sp>
-      <p:sp>
-        <p:nvSpPr>
-          <p:cNvPr id="4" name="Text 2"/>
-          <p:cNvSpPr txBox="1"/>
-          <p:nvPr/>
-        </p:nvSpPr>
-        <p:spPr>
-          <a:xfrm>
-            <a:off x="914400" y="1783080"/>
-            <a:ext cx="4663440" cy="365760"/>
+            <a:ext cx="5394960" cy="4754880"/>
           </a:xfrm>
           <a:prstGeom prst="rect">
             <a:avLst/>
@@ -7405,53 +7770,13 @@
           <a:lstStyle/>
           <a:p>
             <a:pPr indent="0" marL="0">
-              <a:buNone/>
-            </a:pPr>
-            <a:r>
-              <a:rPr lang="en-US" sz="1300" b="1" spc="100" kern="0" dirty="0">
-                <a:solidFill>
-                  <a:srgbClr val="1E2761"/>
-                </a:solidFill>
-                <a:latin typeface="Calibri" pitchFamily="34" charset="0"/>
-                <a:ea typeface="Calibri" pitchFamily="34" charset="-122"/>
-                <a:cs typeface="Calibri" pitchFamily="34" charset="-120"/>
-              </a:rPr>
-              <a:t>VALIDATION AGAINST REAL MARKET DATA</a:t>
-            </a:r>
-            <a:endParaRPr lang="en-US" sz="1300" dirty="0"/>
-          </a:p>
-        </p:txBody>
-      </p:sp>
-      <p:sp>
-        <p:nvSpPr>
-          <p:cNvPr id="5" name="Text 3"/>
-          <p:cNvSpPr txBox="1"/>
-          <p:nvPr/>
-        </p:nvSpPr>
-        <p:spPr>
-          <a:xfrm>
-            <a:off x="914400" y="2286000"/>
-            <a:ext cx="4663440" cy="3474720"/>
-          </a:xfrm>
-          <a:prstGeom prst="rect">
-            <a:avLst/>
-          </a:prstGeom>
-          <a:noFill/>
-          <a:ln/>
-        </p:spPr>
-        <p:txBody>
-          <a:bodyPr wrap="square" lIns="0" tIns="0" rIns="0" bIns="0" rtlCol="0" anchor="ctr"/>
-          <a:lstStyle/>
-          <a:p>
-            <a:pPr marL="342900" indent="-342900">
               <a:spcAft>
-                <a:spcPts val="1200"/>
+                <a:spcPts val="400"/>
               </a:spcAft>
-              <a:buSzPct val="100000"/>
-              <a:buChar char="•"/>
-            </a:pPr>
-            <a:r>
-              <a:rPr lang="en-US" sz="1400" dirty="0">
+              <a:buNone/>
+            </a:pPr>
+            <a:r>
+              <a:rPr lang="en-US" sz="1500" b="1" dirty="0">
                 <a:solidFill>
                   <a:srgbClr val="1B1F3B"/>
                 </a:solidFill>
@@ -7459,20 +7784,39 @@
                 <a:ea typeface="Calibri" pitchFamily="34" charset="-122"/>
                 <a:cs typeface="Calibri" pitchFamily="34" charset="-120"/>
               </a:rPr>
-              <a:t>Pull a real options chain (e.g. NSE/Yahoo Finance)</a:t>
-            </a:r>
-            <a:endParaRPr lang="en-US" sz="1400" dirty="0"/>
-          </a:p>
-          <a:p>
-            <a:pPr marL="342900" indent="-342900">
+              <a:t>The real market shows the same skew direction</a:t>
+            </a:r>
+            <a:endParaRPr lang="en-US" sz="1500" dirty="0"/>
+          </a:p>
+          <a:p>
+            <a:pPr indent="0" marL="0">
               <a:spcAft>
-                <a:spcPts val="1200"/>
+                <a:spcPts val="400"/>
               </a:spcAft>
-              <a:buSzPct val="100000"/>
-              <a:buChar char="•"/>
-            </a:pPr>
-            <a:r>
-              <a:rPr lang="en-US" sz="1400" dirty="0">
+              <a:buNone/>
+            </a:pPr>
+            <a:r>
+              <a:rPr lang="en-US" sz="1300" dirty="0">
+                <a:solidFill>
+                  <a:srgbClr val="6B7280"/>
+                </a:solidFill>
+                <a:latin typeface="Calibri" pitchFamily="34" charset="0"/>
+                <a:ea typeface="Calibri" pitchFamily="34" charset="-122"/>
+                <a:cs typeface="Calibri" pitchFamily="34" charset="-120"/>
+              </a:rPr>
+              <a:t>Negative slope, confirmed: implied vol runs from ~49% down to ~13% near the money — real markets are structurally non-flat, exactly as predicted.</a:t>
+            </a:r>
+            <a:endParaRPr lang="en-US" sz="1500" dirty="0"/>
+          </a:p>
+          <a:p>
+            <a:pPr indent="0" marL="0">
+              <a:spcAft>
+                <a:spcPts val="400"/>
+              </a:spcAft>
+              <a:buNone/>
+            </a:pPr>
+            <a:r>
+              <a:rPr lang="en-US" sz="600" dirty="0">
                 <a:solidFill>
                   <a:srgbClr val="1B1F3B"/>
                 </a:solidFill>
@@ -7480,20 +7824,19 @@
                 <a:ea typeface="Calibri" pitchFamily="34" charset="-122"/>
                 <a:cs typeface="Calibri" pitchFamily="34" charset="-120"/>
               </a:rPr>
-              <a:t>Run the same calibration pipeline on live market prices instead of synthetic ones</a:t>
-            </a:r>
-            <a:endParaRPr lang="en-US" sz="1400" dirty="0"/>
-          </a:p>
-          <a:p>
-            <a:pPr marL="342900" indent="-342900">
+              <a:t> </a:t>
+            </a:r>
+            <a:endParaRPr lang="en-US" sz="1500" dirty="0"/>
+          </a:p>
+          <a:p>
+            <a:pPr indent="0" marL="0">
               <a:spcAft>
-                <a:spcPts val="1200"/>
+                <a:spcPts val="400"/>
               </a:spcAft>
-              <a:buSzPct val="100000"/>
-              <a:buChar char="•"/>
-            </a:pPr>
-            <a:r>
-              <a:rPr lang="en-US" sz="1400" dirty="0">
+              <a:buNone/>
+            </a:pPr>
+            <a:r>
+              <a:rPr lang="en-US" sz="1500" b="1" dirty="0">
                 <a:solidFill>
                   <a:srgbClr val="1B1F3B"/>
                 </a:solidFill>
@@ -7501,20 +7844,39 @@
                 <a:ea typeface="Calibri" pitchFamily="34" charset="-122"/>
                 <a:cs typeface="Calibri" pitchFamily="34" charset="-120"/>
               </a:rPr>
-              <a:t>Check that our confidence ranges actually contain the true market-consistent prices</a:t>
-            </a:r>
-            <a:endParaRPr lang="en-US" sz="1400" dirty="0"/>
-          </a:p>
-          <a:p>
-            <a:pPr marL="342900" indent="-342900">
+              <a:t>Honest caveat: not apples-to-apples (yet)</a:t>
+            </a:r>
+            <a:endParaRPr lang="en-US" sz="1500" dirty="0"/>
+          </a:p>
+          <a:p>
+            <a:pPr indent="0" marL="0">
               <a:spcAft>
-                <a:spcPts val="1200"/>
+                <a:spcPts val="400"/>
               </a:spcAft>
-              <a:buSzPct val="100000"/>
-              <a:buChar char="•"/>
-            </a:pPr>
-            <a:r>
-              <a:rPr lang="en-US" sz="1400" dirty="0">
+              <a:buNone/>
+            </a:pPr>
+            <a:r>
+              <a:rPr lang="en-US" sz="1300" dirty="0">
+                <a:solidFill>
+                  <a:srgbClr val="6B7280"/>
+                </a:solidFill>
+                <a:latin typeface="Calibri" pitchFamily="34" charset="0"/>
+                <a:ea typeface="Calibri" pitchFamily="34" charset="-122"/>
+                <a:cs typeface="Calibri" pitchFamily="34" charset="-120"/>
+              </a:rPr>
+              <a:t>This real chain is ~29 days to expiry vs. 1 year for our synthetic example — short-dated skews run naturally steeper. Compare shape, not scale.</a:t>
+            </a:r>
+            <a:endParaRPr lang="en-US" sz="1500" dirty="0"/>
+          </a:p>
+          <a:p>
+            <a:pPr indent="0" marL="0">
+              <a:spcAft>
+                <a:spcPts val="400"/>
+              </a:spcAft>
+              <a:buNone/>
+            </a:pPr>
+            <a:r>
+              <a:rPr lang="en-US" sz="600" dirty="0">
                 <a:solidFill>
                   <a:srgbClr val="1B1F3B"/>
                 </a:solidFill>
@@ -7522,314 +7884,55 @@
                 <a:ea typeface="Calibri" pitchFamily="34" charset="-122"/>
                 <a:cs typeface="Calibri" pitchFamily="34" charset="-120"/>
               </a:rPr>
-              <a:t>Compare ML calibrator vs. baseline optimizer on real, noisier data</a:t>
-            </a:r>
-            <a:endParaRPr lang="en-US" sz="1400" dirty="0"/>
-          </a:p>
-        </p:txBody>
-      </p:sp>
-      <p:sp>
-        <p:nvSpPr>
-          <p:cNvPr id="6" name="Shape 4"/>
-          <p:cNvSpPr/>
-          <p:nvPr/>
-        </p:nvSpPr>
-        <p:spPr>
-          <a:xfrm>
-            <a:off x="6126480" y="1463040"/>
-            <a:ext cx="5532120" cy="4572000"/>
-          </a:xfrm>
-          <a:prstGeom prst="roundRect">
-            <a:avLst>
-              <a:gd name="adj" fmla="val 1600"/>
-            </a:avLst>
-          </a:prstGeom>
-          <a:solidFill>
-            <a:srgbClr val="1E2761"/>
-          </a:solidFill>
-          <a:ln/>
-          <a:effectLst>
-            <a:outerShdw sx="100000" sy="100000" kx="0" ky="0" algn="bl" rotWithShape="0" blurRad="76200" dist="25400" dir="5400000">
-              <a:srgbClr val="000000">
-                <a:alpha val="12000"/>
-              </a:srgbClr>
-            </a:outerShdw>
-          </a:effectLst>
-        </p:spPr>
-      </p:sp>
-      <p:sp>
-        <p:nvSpPr>
-          <p:cNvPr id="7" name="Text 5"/>
-          <p:cNvSpPr txBox="1"/>
-          <p:nvPr/>
-        </p:nvSpPr>
-        <p:spPr>
-          <a:xfrm>
-            <a:off x="6492240" y="1783080"/>
-            <a:ext cx="4846320" cy="365760"/>
-          </a:xfrm>
-          <a:prstGeom prst="rect">
-            <a:avLst/>
-          </a:prstGeom>
-          <a:noFill/>
-          <a:ln/>
-        </p:spPr>
-        <p:txBody>
-          <a:bodyPr wrap="square" lIns="0" tIns="0" rIns="0" bIns="0" rtlCol="0" anchor="ctr"/>
-          <a:lstStyle/>
+              <a:t> </a:t>
+            </a:r>
+            <a:endParaRPr lang="en-US" sz="1500" dirty="0"/>
+          </a:p>
           <a:p>
             <a:pPr indent="0" marL="0">
-              <a:buNone/>
-            </a:pPr>
-            <a:r>
-              <a:rPr lang="en-US" sz="1300" b="1" spc="100" kern="0" dirty="0">
-                <a:solidFill>
-                  <a:srgbClr val="C9A227"/>
-                </a:solidFill>
-                <a:latin typeface="Calibri" pitchFamily="34" charset="0"/>
-                <a:ea typeface="Calibri" pitchFamily="34" charset="-122"/>
-                <a:cs typeface="Calibri" pitchFamily="34" charset="-120"/>
-              </a:rPr>
-              <a:t>EVERYTHING IS REPRODUCIBLE</a:t>
-            </a:r>
-            <a:endParaRPr lang="en-US" sz="1300" dirty="0"/>
-          </a:p>
-        </p:txBody>
-      </p:sp>
-      <p:sp>
-        <p:nvSpPr>
-          <p:cNvPr id="8" name="Text 6"/>
-          <p:cNvSpPr txBox="1"/>
-          <p:nvPr/>
-        </p:nvSpPr>
-        <p:spPr>
-          <a:xfrm>
-            <a:off x="6492240" y="2240280"/>
-            <a:ext cx="4846320" cy="822960"/>
-          </a:xfrm>
-          <a:prstGeom prst="rect">
-            <a:avLst/>
-          </a:prstGeom>
-          <a:noFill/>
-          <a:ln/>
-        </p:spPr>
-        <p:txBody>
-          <a:bodyPr wrap="square" lIns="0" tIns="0" rIns="0" bIns="0" rtlCol="0" anchor="ctr"/>
-          <a:lstStyle/>
+              <a:spcAft>
+                <a:spcPts val="400"/>
+              </a:spcAft>
+              <a:buNone/>
+            </a:pPr>
+            <a:r>
+              <a:rPr lang="en-US" sz="1500" b="1" dirty="0">
+                <a:solidFill>
+                  <a:srgbClr val="1B1F3B"/>
+                </a:solidFill>
+                <a:latin typeface="Calibri" pitchFamily="34" charset="0"/>
+                <a:ea typeface="Calibri" pitchFamily="34" charset="-122"/>
+                <a:cs typeface="Calibri" pitchFamily="34" charset="-120"/>
+              </a:rPr>
+              <a:t>Also attempted: NSE India (NIFTY)</a:t>
+            </a:r>
+            <a:endParaRPr lang="en-US" sz="1500" dirty="0"/>
+          </a:p>
           <a:p>
             <a:pPr indent="0" marL="0">
-              <a:buNone/>
-            </a:pPr>
-            <a:r>
-              <a:rPr lang="en-US" sz="1400" dirty="0">
-                <a:solidFill>
-                  <a:srgbClr val="E6E9F5"/>
-                </a:solidFill>
-                <a:latin typeface="Calibri" pitchFamily="34" charset="0"/>
-                <a:ea typeface="Calibri" pitchFamily="34" charset="-122"/>
-                <a:cs typeface="Calibri" pitchFamily="34" charset="-120"/>
-              </a:rPr>
-              <a:t>All code for Steps 1–6 is written, tested, and documented — open to inspection, not just described in slides.</a:t>
-            </a:r>
-            <a:endParaRPr lang="en-US" sz="1400" dirty="0"/>
-          </a:p>
-        </p:txBody>
-      </p:sp>
-      <p:sp>
-        <p:nvSpPr>
-          <p:cNvPr id="9" name="Shape 7"/>
-          <p:cNvSpPr/>
-          <p:nvPr/>
-        </p:nvSpPr>
-        <p:spPr>
-          <a:xfrm>
-            <a:off x="6492240" y="3246120"/>
-            <a:ext cx="4846320" cy="914400"/>
-          </a:xfrm>
-          <a:prstGeom prst="roundRect">
-            <a:avLst>
-              <a:gd name="adj" fmla="val 8000"/>
-            </a:avLst>
-          </a:prstGeom>
-          <a:solidFill>
-            <a:srgbClr val="151B38"/>
-          </a:solidFill>
-          <a:ln/>
-          <a:effectLst>
-            <a:outerShdw sx="100000" sy="100000" kx="0" ky="0" algn="bl" rotWithShape="0" blurRad="76200" dist="25400" dir="5400000">
-              <a:srgbClr val="000000">
-                <a:alpha val="12000"/>
-              </a:srgbClr>
-            </a:outerShdw>
-          </a:effectLst>
-        </p:spPr>
-      </p:sp>
-      <p:sp>
-        <p:nvSpPr>
-          <p:cNvPr id="10" name="Text 8"/>
-          <p:cNvSpPr txBox="1"/>
-          <p:nvPr/>
-        </p:nvSpPr>
-        <p:spPr>
-          <a:xfrm>
-            <a:off x="6675120" y="3364992"/>
-            <a:ext cx="4572000" cy="320040"/>
-          </a:xfrm>
-          <a:prstGeom prst="rect">
-            <a:avLst/>
-          </a:prstGeom>
-          <a:noFill/>
-          <a:ln/>
-        </p:spPr>
-        <p:txBody>
-          <a:bodyPr wrap="square" lIns="0" tIns="0" rIns="0" bIns="0" rtlCol="0" anchor="ctr"/>
-          <a:lstStyle/>
-          <a:p>
-            <a:pPr indent="0" marL="0">
-              <a:buNone/>
-            </a:pPr>
-            <a:r>
-              <a:rPr lang="en-US" sz="1400" dirty="0">
-                <a:solidFill>
-                  <a:srgbClr val="FFFFFF"/>
-                </a:solidFill>
-                <a:latin typeface="Calibri" pitchFamily="34" charset="0"/>
-                <a:ea typeface="Calibri" pitchFamily="34" charset="-122"/>
-                <a:cs typeface="Calibri" pitchFamily="34" charset="-120"/>
-              </a:rPr>
-              <a:t>github.com/pastbologanesh0101/</a:t>
-            </a:r>
-            <a:endParaRPr lang="en-US" sz="1400" dirty="0"/>
-          </a:p>
-        </p:txBody>
-      </p:sp>
-      <p:sp>
-        <p:nvSpPr>
-          <p:cNvPr id="11" name="Text 9"/>
-          <p:cNvSpPr txBox="1"/>
-          <p:nvPr/>
-        </p:nvSpPr>
-        <p:spPr>
-          <a:xfrm>
-            <a:off x="6675120" y="3657600"/>
-            <a:ext cx="4572000" cy="365760"/>
-          </a:xfrm>
-          <a:prstGeom prst="rect">
-            <a:avLst/>
-          </a:prstGeom>
-          <a:noFill/>
-          <a:ln/>
-        </p:spPr>
-        <p:txBody>
-          <a:bodyPr wrap="square" lIns="0" tIns="0" rIns="0" bIns="0" rtlCol="0" anchor="ctr"/>
-          <a:lstStyle/>
-          <a:p>
-            <a:pPr indent="0" marL="0">
-              <a:buNone/>
-            </a:pPr>
-            <a:r>
-              <a:rPr lang="en-US" sz="1800" b="1" dirty="0">
-                <a:solidFill>
-                  <a:srgbClr val="C9A227"/>
-                </a:solidFill>
-                <a:latin typeface="Cambria" pitchFamily="34" charset="0"/>
-                <a:ea typeface="Cambria" pitchFamily="34" charset="-122"/>
-                <a:cs typeface="Cambria" pitchFamily="34" charset="-120"/>
-              </a:rPr>
-              <a:t>option-pricing-heston</a:t>
-            </a:r>
-            <a:endParaRPr lang="en-US" sz="1800" dirty="0"/>
-          </a:p>
-        </p:txBody>
-      </p:sp>
-      <p:sp>
-        <p:nvSpPr>
-          <p:cNvPr id="12" name="Text 10"/>
-          <p:cNvSpPr txBox="1"/>
-          <p:nvPr/>
-        </p:nvSpPr>
-        <p:spPr>
-          <a:xfrm>
-            <a:off x="6492240" y="4343400"/>
-            <a:ext cx="4846320" cy="1554480"/>
-          </a:xfrm>
-          <a:prstGeom prst="rect">
-            <a:avLst/>
-          </a:prstGeom>
-          <a:noFill/>
-          <a:ln/>
-        </p:spPr>
-        <p:txBody>
-          <a:bodyPr wrap="square" lIns="0" tIns="0" rIns="0" bIns="0" rtlCol="0" anchor="ctr"/>
-          <a:lstStyle/>
-          <a:p>
-            <a:pPr marL="342900" indent="-342900">
               <a:spcAft>
-                <a:spcPts val="800"/>
+                <a:spcPts val="400"/>
               </a:spcAft>
-              <a:buSzPct val="100000"/>
-              <a:buChar char="•"/>
+              <a:buNone/>
             </a:pPr>
             <a:r>
               <a:rPr lang="en-US" sz="1300" dirty="0">
                 <a:solidFill>
-                  <a:srgbClr val="CADCFC"/>
-                </a:solidFill>
-                <a:latin typeface="Calibri" pitchFamily="34" charset="0"/>
-                <a:ea typeface="Calibri" pitchFamily="34" charset="-122"/>
-                <a:cs typeface="Calibri" pitchFamily="34" charset="-120"/>
-              </a:rPr>
-              <a:t>7 Python modules</a:t>
-            </a:r>
-            <a:endParaRPr lang="en-US" sz="1300" dirty="0"/>
-          </a:p>
-          <a:p>
-            <a:pPr marL="342900" indent="-342900">
-              <a:spcAft>
-                <a:spcPts val="800"/>
-              </a:spcAft>
-              <a:buSzPct val="100000"/>
-              <a:buChar char="•"/>
-            </a:pPr>
-            <a:r>
-              <a:rPr lang="en-US" sz="1300" dirty="0">
-                <a:solidFill>
-                  <a:srgbClr val="CADCFC"/>
-                </a:solidFill>
-                <a:latin typeface="Calibri" pitchFamily="34" charset="0"/>
-                <a:ea typeface="Calibri" pitchFamily="34" charset="-122"/>
-                <a:cs typeface="Calibri" pitchFamily="34" charset="-120"/>
-              </a:rPr>
-              <a:t>Full progress write-up (PROGRESS.md)</a:t>
-            </a:r>
-            <a:endParaRPr lang="en-US" sz="1300" dirty="0"/>
-          </a:p>
-          <a:p>
-            <a:pPr marL="342900" indent="-342900">
-              <a:spcAft>
-                <a:spcPts val="800"/>
-              </a:spcAft>
-              <a:buSzPct val="100000"/>
-              <a:buChar char="•"/>
-            </a:pPr>
-            <a:r>
-              <a:rPr lang="en-US" sz="1300" dirty="0">
-                <a:solidFill>
-                  <a:srgbClr val="CADCFC"/>
-                </a:solidFill>
-                <a:latin typeface="Calibri" pitchFamily="34" charset="0"/>
-                <a:ea typeface="Calibri" pitchFamily="34" charset="-122"/>
-                <a:cs typeface="Calibri" pitchFamily="34" charset="-120"/>
-              </a:rPr>
-              <a:t>6,000-row training dataset included</a:t>
-            </a:r>
-            <a:endParaRPr lang="en-US" sz="1300" dirty="0"/>
-          </a:p>
-        </p:txBody>
-      </p:sp>
-      <p:sp>
-        <p:nvSpPr>
-          <p:cNvPr id="13" name="Text 1"/>
+                  <a:srgbClr val="6B7280"/>
+                </a:solidFill>
+                <a:latin typeface="Calibri" pitchFamily="34" charset="0"/>
+                <a:ea typeface="Calibri" pitchFamily="34" charset="-122"/>
+                <a:cs typeface="Calibri" pitchFamily="34" charset="-120"/>
+              </a:rPr>
+              <a:t>Blocked by NSE's bot detection — a known, documented limitation, not hidden. yfinance/SPY is the reliable path we kept.</a:t>
+            </a:r>
+            <a:endParaRPr lang="en-US" sz="1500" dirty="0"/>
+          </a:p>
+        </p:txBody>
+      </p:sp>
+      <p:sp>
+        <p:nvSpPr>
+          <p:cNvPr id="6" name="Text 1"/>
           <p:cNvSpPr/>
           <p:nvPr>
             <p:ph idx="102" type="body" hasCustomPrompt="1"/>
@@ -7932,164 +8035,7 @@
       </p:grpSpPr>
       <p:sp>
         <p:nvSpPr>
-          <p:cNvPr id="2" name="Shape 0"/>
-          <p:cNvSpPr/>
-          <p:nvPr/>
-        </p:nvSpPr>
-        <p:spPr>
-          <a:xfrm>
-            <a:off x="9646920" y="4206240"/>
-            <a:ext cx="2011680" cy="2011680"/>
-          </a:xfrm>
-          <a:prstGeom prst="ellipse">
-            <a:avLst/>
-          </a:prstGeom>
-          <a:solidFill>
-            <a:srgbClr val="2A3570"/>
-          </a:solidFill>
-          <a:ln/>
-        </p:spPr>
-      </p:sp>
-      <p:sp>
-        <p:nvSpPr>
-          <p:cNvPr id="3" name="Shape 1"/>
-          <p:cNvSpPr/>
-          <p:nvPr/>
-        </p:nvSpPr>
-        <p:spPr>
-          <a:xfrm>
-            <a:off x="10012680" y="4572000"/>
-            <a:ext cx="1280160" cy="1280160"/>
-          </a:xfrm>
-          <a:prstGeom prst="ellipse">
-            <a:avLst/>
-          </a:prstGeom>
-          <a:solidFill>
-            <a:srgbClr val="C9A227"/>
-          </a:solidFill>
-          <a:ln/>
-        </p:spPr>
-      </p:sp>
-      <p:sp>
-        <p:nvSpPr>
-          <p:cNvPr id="4" name="Text 2"/>
-          <p:cNvSpPr txBox="1"/>
-          <p:nvPr/>
-        </p:nvSpPr>
-        <p:spPr>
-          <a:xfrm>
-            <a:off x="731520" y="2377440"/>
-            <a:ext cx="7315200" cy="1005840"/>
-          </a:xfrm>
-          <a:prstGeom prst="rect">
-            <a:avLst/>
-          </a:prstGeom>
-          <a:noFill/>
-          <a:ln/>
-        </p:spPr>
-        <p:txBody>
-          <a:bodyPr wrap="square" lIns="0" tIns="0" rIns="0" bIns="0" rtlCol="0" anchor="ctr"/>
-          <a:lstStyle/>
-          <a:p>
-            <a:pPr indent="0" marL="0">
-              <a:buNone/>
-            </a:pPr>
-            <a:r>
-              <a:rPr lang="en-US" sz="4400" b="1" dirty="0">
-                <a:solidFill>
-                  <a:srgbClr val="FFFFFF"/>
-                </a:solidFill>
-                <a:latin typeface="Cambria" pitchFamily="34" charset="0"/>
-                <a:ea typeface="Cambria" pitchFamily="34" charset="-122"/>
-                <a:cs typeface="Cambria" pitchFamily="34" charset="-120"/>
-              </a:rPr>
-              <a:t>Thank You</a:t>
-            </a:r>
-            <a:endParaRPr lang="en-US" sz="4400" dirty="0"/>
-          </a:p>
-        </p:txBody>
-      </p:sp>
-      <p:sp>
-        <p:nvSpPr>
-          <p:cNvPr id="5" name="Text 3"/>
-          <p:cNvSpPr txBox="1"/>
-          <p:nvPr/>
-        </p:nvSpPr>
-        <p:spPr>
-          <a:xfrm>
-            <a:off x="731520" y="3429000"/>
-            <a:ext cx="7772400" cy="548640"/>
-          </a:xfrm>
-          <a:prstGeom prst="rect">
-            <a:avLst/>
-          </a:prstGeom>
-          <a:noFill/>
-          <a:ln/>
-        </p:spPr>
-        <p:txBody>
-          <a:bodyPr wrap="square" lIns="0" tIns="0" rIns="0" bIns="0" rtlCol="0" anchor="ctr"/>
-          <a:lstStyle/>
-          <a:p>
-            <a:pPr indent="0" marL="0">
-              <a:buNone/>
-            </a:pPr>
-            <a:r>
-              <a:rPr lang="en-US" sz="1600" dirty="0">
-                <a:solidFill>
-                  <a:srgbClr val="CADCFC"/>
-                </a:solidFill>
-                <a:latin typeface="Calibri" pitchFamily="34" charset="0"/>
-                <a:ea typeface="Calibri" pitchFamily="34" charset="-122"/>
-                <a:cs typeface="Calibri" pitchFamily="34" charset="-120"/>
-              </a:rPr>
-              <a:t>Questions welcome — code, data, and results are all open for review.</a:t>
-            </a:r>
-            <a:endParaRPr lang="en-US" sz="1600" dirty="0"/>
-          </a:p>
-        </p:txBody>
-      </p:sp>
-      <p:sp>
-        <p:nvSpPr>
-          <p:cNvPr id="6" name="Text 4"/>
-          <p:cNvSpPr txBox="1"/>
-          <p:nvPr/>
-        </p:nvSpPr>
-        <p:spPr>
-          <a:xfrm>
-            <a:off x="731520" y="5120640"/>
-            <a:ext cx="7315200" cy="365760"/>
-          </a:xfrm>
-          <a:prstGeom prst="rect">
-            <a:avLst/>
-          </a:prstGeom>
-          <a:noFill/>
-          <a:ln/>
-        </p:spPr>
-        <p:txBody>
-          <a:bodyPr wrap="square" lIns="0" tIns="0" rIns="0" bIns="0" rtlCol="0" anchor="ctr"/>
-          <a:lstStyle/>
-          <a:p>
-            <a:pPr indent="0" marL="0">
-              <a:buNone/>
-            </a:pPr>
-            <a:r>
-              <a:rPr lang="en-US" sz="1400" i="1" dirty="0">
-                <a:solidFill>
-                  <a:srgbClr val="C9A227"/>
-                </a:solidFill>
-                <a:latin typeface="Calibri" pitchFamily="34" charset="0"/>
-                <a:ea typeface="Calibri" pitchFamily="34" charset="-122"/>
-                <a:cs typeface="Calibri" pitchFamily="34" charset="-120"/>
-              </a:rPr>
-              <a:t>github.com/pastbologanesh0101/option-pricing-heston</a:t>
-            </a:r>
-            <a:endParaRPr lang="en-US" sz="1400" dirty="0"/>
-          </a:p>
-        </p:txBody>
-      </p:sp>
-      <p:sp>
-        <p:nvSpPr>
-          <p:cNvPr id="7" name="Text 0"/>
+          <p:cNvPr id="2" name="Text 0"/>
           <p:cNvSpPr/>
           <p:nvPr>
             <p:ph idx="100" type="title" hasCustomPrompt="1"/>
@@ -8097,8 +8043,8 @@
         </p:nvSpPr>
         <p:spPr>
           <a:xfrm>
-            <a:off x="731520" y="2514600"/>
-            <a:ext cx="9326880" cy="1463040"/>
+            <a:off x="548640" y="411480"/>
+            <a:ext cx="10607040" cy="731520"/>
           </a:xfrm>
           <a:prstGeom prst="rect">
             <a:avLst/>
@@ -8113,37 +8059,569 @@
             <a:pPr algn="l" indent="0" marL="0">
               <a:buNone/>
             </a:pPr>
-            <a:endParaRPr lang="en-US" sz="4000" dirty="0"/>
-          </a:p>
-        </p:txBody>
-      </p:sp>
-      <p:sp>
-        <p:nvSpPr>
-          <p:cNvPr id="8" name="Text 0"/>
+            <a:r>
+              <a:rPr lang="en-US" sz="3000" b="1" dirty="0">
+                <a:solidFill>
+                  <a:srgbClr val="1B1F3B"/>
+                </a:solidFill>
+                <a:latin typeface="Cambria" pitchFamily="34" charset="0"/>
+                <a:ea typeface="Cambria" pitchFamily="34" charset="-122"/>
+                <a:cs typeface="Cambria" pitchFamily="34" charset="-120"/>
+              </a:rPr>
+              <a:t>What's Left to Finish Step 7</a:t>
+            </a:r>
+            <a:endParaRPr lang="en-US" sz="3000" dirty="0"/>
+          </a:p>
+        </p:txBody>
+      </p:sp>
+      <p:sp>
+        <p:nvSpPr>
+          <p:cNvPr id="3" name="Shape 1"/>
+          <p:cNvSpPr/>
+          <p:nvPr/>
+        </p:nvSpPr>
+        <p:spPr>
+          <a:xfrm>
+            <a:off x="548640" y="1463040"/>
+            <a:ext cx="5349240" cy="4572000"/>
+          </a:xfrm>
+          <a:prstGeom prst="roundRect">
+            <a:avLst>
+              <a:gd name="adj" fmla="val 1600"/>
+            </a:avLst>
+          </a:prstGeom>
+          <a:solidFill>
+            <a:srgbClr val="F0F1F7"/>
+          </a:solidFill>
+          <a:ln/>
+          <a:effectLst>
+            <a:outerShdw sx="100000" sy="100000" kx="0" ky="0" algn="bl" rotWithShape="0" blurRad="76200" dist="25400" dir="5400000">
+              <a:srgbClr val="000000">
+                <a:alpha val="12000"/>
+              </a:srgbClr>
+            </a:outerShdw>
+          </a:effectLst>
+        </p:spPr>
+      </p:sp>
+      <p:sp>
+        <p:nvSpPr>
+          <p:cNvPr id="4" name="Text 2"/>
+          <p:cNvSpPr txBox="1"/>
+          <p:nvPr/>
+        </p:nvSpPr>
+        <p:spPr>
+          <a:xfrm>
+            <a:off x="914400" y="1783080"/>
+            <a:ext cx="4663440" cy="365760"/>
+          </a:xfrm>
+          <a:prstGeom prst="rect">
+            <a:avLst/>
+          </a:prstGeom>
+          <a:noFill/>
+          <a:ln/>
+        </p:spPr>
+        <p:txBody>
+          <a:bodyPr wrap="square" lIns="0" tIns="0" rIns="0" bIns="0" rtlCol="0" anchor="ctr"/>
+          <a:lstStyle/>
+          <a:p>
+            <a:pPr indent="0" marL="0">
+              <a:buNone/>
+            </a:pPr>
+            <a:r>
+              <a:rPr lang="en-US" sz="1300" b="1" spc="100" kern="0" dirty="0">
+                <a:solidFill>
+                  <a:srgbClr val="1E2761"/>
+                </a:solidFill>
+                <a:latin typeface="Calibri" pitchFamily="34" charset="0"/>
+                <a:ea typeface="Calibri" pitchFamily="34" charset="-122"/>
+                <a:cs typeface="Calibri" pitchFamily="34" charset="-120"/>
+              </a:rPr>
+              <a:t>FROM SHAPE-MATCHING TO TRUE CALIBRATION</a:t>
+            </a:r>
+            <a:endParaRPr lang="en-US" sz="1300" dirty="0"/>
+          </a:p>
+        </p:txBody>
+      </p:sp>
+      <p:sp>
+        <p:nvSpPr>
+          <p:cNvPr id="5" name="Text 3"/>
+          <p:cNvSpPr txBox="1"/>
+          <p:nvPr/>
+        </p:nvSpPr>
+        <p:spPr>
+          <a:xfrm>
+            <a:off x="914400" y="2286000"/>
+            <a:ext cx="4663440" cy="3474720"/>
+          </a:xfrm>
+          <a:prstGeom prst="rect">
+            <a:avLst/>
+          </a:prstGeom>
+          <a:noFill/>
+          <a:ln/>
+        </p:spPr>
+        <p:txBody>
+          <a:bodyPr wrap="square" lIns="0" tIns="0" rIns="0" bIns="0" rtlCol="0" anchor="ctr"/>
+          <a:lstStyle/>
+          <a:p>
+            <a:pPr marL="342900" indent="-342900">
+              <a:spcAft>
+                <a:spcPts val="1200"/>
+              </a:spcAft>
+              <a:buSzPct val="100000"/>
+              <a:buChar char="•"/>
+            </a:pPr>
+            <a:r>
+              <a:rPr lang="en-US" sz="1400" dirty="0">
+                <a:solidFill>
+                  <a:srgbClr val="1B1F3B"/>
+                </a:solidFill>
+                <a:latin typeface="Calibri" pitchFamily="34" charset="0"/>
+                <a:ea typeface="Calibri" pitchFamily="34" charset="-122"/>
+                <a:cs typeface="Calibri" pitchFamily="34" charset="-120"/>
+              </a:rPr>
+              <a:t>Feed the live SPY chain into calibration.py / ml_calibration.py directly</a:t>
+            </a:r>
+            <a:endParaRPr lang="en-US" sz="1400" dirty="0"/>
+          </a:p>
+          <a:p>
+            <a:pPr marL="342900" indent="-342900">
+              <a:spcAft>
+                <a:spcPts val="1200"/>
+              </a:spcAft>
+              <a:buSzPct val="100000"/>
+              <a:buChar char="•"/>
+            </a:pPr>
+            <a:r>
+              <a:rPr lang="en-US" sz="1400" dirty="0">
+                <a:solidFill>
+                  <a:srgbClr val="1B1F3B"/>
+                </a:solidFill>
+                <a:latin typeface="Calibri" pitchFamily="34" charset="0"/>
+                <a:ea typeface="Calibri" pitchFamily="34" charset="-122"/>
+                <a:cs typeface="Calibri" pitchFamily="34" charset="-120"/>
+              </a:rPr>
+              <a:t>Recover the Heston parameters that actually fit today's market, not just compare shapes</a:t>
+            </a:r>
+            <a:endParaRPr lang="en-US" sz="1400" dirty="0"/>
+          </a:p>
+          <a:p>
+            <a:pPr marL="342900" indent="-342900">
+              <a:spcAft>
+                <a:spcPts val="1200"/>
+              </a:spcAft>
+              <a:buSzPct val="100000"/>
+              <a:buChar char="•"/>
+            </a:pPr>
+            <a:r>
+              <a:rPr lang="en-US" sz="1400" dirty="0">
+                <a:solidFill>
+                  <a:srgbClr val="1B1F3B"/>
+                </a:solidFill>
+                <a:latin typeface="Calibri" pitchFamily="34" charset="0"/>
+                <a:ea typeface="Calibri" pitchFamily="34" charset="-122"/>
+                <a:cs typeface="Calibri" pitchFamily="34" charset="-120"/>
+              </a:rPr>
+              <a:t>Check that our confidence ranges actually contain the true market-consistent prices</a:t>
+            </a:r>
+            <a:endParaRPr lang="en-US" sz="1400" dirty="0"/>
+          </a:p>
+          <a:p>
+            <a:pPr marL="342900" indent="-342900">
+              <a:spcAft>
+                <a:spcPts val="1200"/>
+              </a:spcAft>
+              <a:buSzPct val="100000"/>
+              <a:buChar char="•"/>
+            </a:pPr>
+            <a:r>
+              <a:rPr lang="en-US" sz="1400" dirty="0">
+                <a:solidFill>
+                  <a:srgbClr val="1B1F3B"/>
+                </a:solidFill>
+                <a:latin typeface="Calibri" pitchFamily="34" charset="0"/>
+                <a:ea typeface="Calibri" pitchFamily="34" charset="-122"/>
+                <a:cs typeface="Calibri" pitchFamily="34" charset="-120"/>
+              </a:rPr>
+              <a:t>Compare ML calibrator vs. baseline optimizer on real, noisier data</a:t>
+            </a:r>
+            <a:endParaRPr lang="en-US" sz="1400" dirty="0"/>
+          </a:p>
+        </p:txBody>
+      </p:sp>
+      <p:sp>
+        <p:nvSpPr>
+          <p:cNvPr id="6" name="Shape 4"/>
+          <p:cNvSpPr/>
+          <p:nvPr/>
+        </p:nvSpPr>
+        <p:spPr>
+          <a:xfrm>
+            <a:off x="6126480" y="1463040"/>
+            <a:ext cx="5532120" cy="4572000"/>
+          </a:xfrm>
+          <a:prstGeom prst="roundRect">
+            <a:avLst>
+              <a:gd name="adj" fmla="val 1600"/>
+            </a:avLst>
+          </a:prstGeom>
+          <a:solidFill>
+            <a:srgbClr val="1E2761"/>
+          </a:solidFill>
+          <a:ln/>
+          <a:effectLst>
+            <a:outerShdw sx="100000" sy="100000" kx="0" ky="0" algn="bl" rotWithShape="0" blurRad="76200" dist="25400" dir="5400000">
+              <a:srgbClr val="000000">
+                <a:alpha val="12000"/>
+              </a:srgbClr>
+            </a:outerShdw>
+          </a:effectLst>
+        </p:spPr>
+      </p:sp>
+      <p:sp>
+        <p:nvSpPr>
+          <p:cNvPr id="7" name="Text 5"/>
+          <p:cNvSpPr txBox="1"/>
+          <p:nvPr/>
+        </p:nvSpPr>
+        <p:spPr>
+          <a:xfrm>
+            <a:off x="6492240" y="1783080"/>
+            <a:ext cx="4846320" cy="365760"/>
+          </a:xfrm>
+          <a:prstGeom prst="rect">
+            <a:avLst/>
+          </a:prstGeom>
+          <a:noFill/>
+          <a:ln/>
+        </p:spPr>
+        <p:txBody>
+          <a:bodyPr wrap="square" lIns="0" tIns="0" rIns="0" bIns="0" rtlCol="0" anchor="ctr"/>
+          <a:lstStyle/>
+          <a:p>
+            <a:pPr indent="0" marL="0">
+              <a:buNone/>
+            </a:pPr>
+            <a:r>
+              <a:rPr lang="en-US" sz="1300" b="1" spc="100" kern="0" dirty="0">
+                <a:solidFill>
+                  <a:srgbClr val="C9A227"/>
+                </a:solidFill>
+                <a:latin typeface="Calibri" pitchFamily="34" charset="0"/>
+                <a:ea typeface="Calibri" pitchFamily="34" charset="-122"/>
+                <a:cs typeface="Calibri" pitchFamily="34" charset="-120"/>
+              </a:rPr>
+              <a:t>EVERYTHING IS REPRODUCIBLE</a:t>
+            </a:r>
+            <a:endParaRPr lang="en-US" sz="1300" dirty="0"/>
+          </a:p>
+        </p:txBody>
+      </p:sp>
+      <p:sp>
+        <p:nvSpPr>
+          <p:cNvPr id="8" name="Text 6"/>
+          <p:cNvSpPr txBox="1"/>
+          <p:nvPr/>
+        </p:nvSpPr>
+        <p:spPr>
+          <a:xfrm>
+            <a:off x="6492240" y="2240280"/>
+            <a:ext cx="4846320" cy="822960"/>
+          </a:xfrm>
+          <a:prstGeom prst="rect">
+            <a:avLst/>
+          </a:prstGeom>
+          <a:noFill/>
+          <a:ln/>
+        </p:spPr>
+        <p:txBody>
+          <a:bodyPr wrap="square" lIns="0" tIns="0" rIns="0" bIns="0" rtlCol="0" anchor="ctr"/>
+          <a:lstStyle/>
+          <a:p>
+            <a:pPr indent="0" marL="0">
+              <a:buNone/>
+            </a:pPr>
+            <a:r>
+              <a:rPr lang="en-US" sz="1400" dirty="0">
+                <a:solidFill>
+                  <a:srgbClr val="E6E9F5"/>
+                </a:solidFill>
+                <a:latin typeface="Calibri" pitchFamily="34" charset="0"/>
+                <a:ea typeface="Calibri" pitchFamily="34" charset="-122"/>
+                <a:cs typeface="Calibri" pitchFamily="34" charset="-120"/>
+              </a:rPr>
+              <a:t>All code for Steps 1–6 is written, tested, and documented — open to inspection, not just described in slides.</a:t>
+            </a:r>
+            <a:endParaRPr lang="en-US" sz="1400" dirty="0"/>
+          </a:p>
+        </p:txBody>
+      </p:sp>
+      <p:sp>
+        <p:nvSpPr>
+          <p:cNvPr id="9" name="Shape 7"/>
+          <p:cNvSpPr/>
+          <p:nvPr/>
+        </p:nvSpPr>
+        <p:spPr>
+          <a:xfrm>
+            <a:off x="6492240" y="3246120"/>
+            <a:ext cx="4846320" cy="914400"/>
+          </a:xfrm>
+          <a:prstGeom prst="roundRect">
+            <a:avLst>
+              <a:gd name="adj" fmla="val 8000"/>
+            </a:avLst>
+          </a:prstGeom>
+          <a:solidFill>
+            <a:srgbClr val="151B38"/>
+          </a:solidFill>
+          <a:ln/>
+          <a:effectLst>
+            <a:outerShdw sx="100000" sy="100000" kx="0" ky="0" algn="bl" rotWithShape="0" blurRad="76200" dist="25400" dir="5400000">
+              <a:srgbClr val="000000">
+                <a:alpha val="12000"/>
+              </a:srgbClr>
+            </a:outerShdw>
+          </a:effectLst>
+        </p:spPr>
+      </p:sp>
+      <p:sp>
+        <p:nvSpPr>
+          <p:cNvPr id="10" name="Text 8"/>
+          <p:cNvSpPr txBox="1"/>
+          <p:nvPr/>
+        </p:nvSpPr>
+        <p:spPr>
+          <a:xfrm>
+            <a:off x="6675120" y="3364992"/>
+            <a:ext cx="4572000" cy="320040"/>
+          </a:xfrm>
+          <a:prstGeom prst="rect">
+            <a:avLst/>
+          </a:prstGeom>
+          <a:noFill/>
+          <a:ln/>
+        </p:spPr>
+        <p:txBody>
+          <a:bodyPr wrap="square" lIns="0" tIns="0" rIns="0" bIns="0" rtlCol="0" anchor="ctr"/>
+          <a:lstStyle/>
+          <a:p>
+            <a:pPr indent="0" marL="0">
+              <a:buNone/>
+            </a:pPr>
+            <a:r>
+              <a:rPr lang="en-US" sz="1400" dirty="0">
+                <a:solidFill>
+                  <a:srgbClr val="FFFFFF"/>
+                </a:solidFill>
+                <a:latin typeface="Calibri" pitchFamily="34" charset="0"/>
+                <a:ea typeface="Calibri" pitchFamily="34" charset="-122"/>
+                <a:cs typeface="Calibri" pitchFamily="34" charset="-120"/>
+              </a:rPr>
+              <a:t>github.com/pastbologanesh0101/</a:t>
+            </a:r>
+            <a:endParaRPr lang="en-US" sz="1400" dirty="0"/>
+          </a:p>
+        </p:txBody>
+      </p:sp>
+      <p:sp>
+        <p:nvSpPr>
+          <p:cNvPr id="11" name="Text 9"/>
+          <p:cNvSpPr txBox="1"/>
+          <p:nvPr/>
+        </p:nvSpPr>
+        <p:spPr>
+          <a:xfrm>
+            <a:off x="6675120" y="3657600"/>
+            <a:ext cx="4572000" cy="365760"/>
+          </a:xfrm>
+          <a:prstGeom prst="rect">
+            <a:avLst/>
+          </a:prstGeom>
+          <a:noFill/>
+          <a:ln/>
+        </p:spPr>
+        <p:txBody>
+          <a:bodyPr wrap="square" lIns="0" tIns="0" rIns="0" bIns="0" rtlCol="0" anchor="ctr"/>
+          <a:lstStyle/>
+          <a:p>
+            <a:pPr indent="0" marL="0">
+              <a:buNone/>
+            </a:pPr>
+            <a:r>
+              <a:rPr lang="en-US" sz="1800" b="1" dirty="0">
+                <a:solidFill>
+                  <a:srgbClr val="C9A227"/>
+                </a:solidFill>
+                <a:latin typeface="Cambria" pitchFamily="34" charset="0"/>
+                <a:ea typeface="Cambria" pitchFamily="34" charset="-122"/>
+                <a:cs typeface="Cambria" pitchFamily="34" charset="-120"/>
+              </a:rPr>
+              <a:t>option-pricing-heston</a:t>
+            </a:r>
+            <a:endParaRPr lang="en-US" sz="1800" dirty="0"/>
+          </a:p>
+        </p:txBody>
+      </p:sp>
+      <p:sp>
+        <p:nvSpPr>
+          <p:cNvPr id="12" name="Text 10"/>
+          <p:cNvSpPr txBox="1"/>
+          <p:nvPr/>
+        </p:nvSpPr>
+        <p:spPr>
+          <a:xfrm>
+            <a:off x="6492240" y="4343400"/>
+            <a:ext cx="4846320" cy="1554480"/>
+          </a:xfrm>
+          <a:prstGeom prst="rect">
+            <a:avLst/>
+          </a:prstGeom>
+          <a:noFill/>
+          <a:ln/>
+        </p:spPr>
+        <p:txBody>
+          <a:bodyPr wrap="square" lIns="0" tIns="0" rIns="0" bIns="0" rtlCol="0" anchor="ctr"/>
+          <a:lstStyle/>
+          <a:p>
+            <a:pPr marL="342900" indent="-342900">
+              <a:spcAft>
+                <a:spcPts val="800"/>
+              </a:spcAft>
+              <a:buSzPct val="100000"/>
+              <a:buChar char="•"/>
+            </a:pPr>
+            <a:r>
+              <a:rPr lang="en-US" sz="1300" dirty="0">
+                <a:solidFill>
+                  <a:srgbClr val="CADCFC"/>
+                </a:solidFill>
+                <a:latin typeface="Calibri" pitchFamily="34" charset="0"/>
+                <a:ea typeface="Calibri" pitchFamily="34" charset="-122"/>
+                <a:cs typeface="Calibri" pitchFamily="34" charset="-120"/>
+              </a:rPr>
+              <a:t>7 Python modules</a:t>
+            </a:r>
+            <a:endParaRPr lang="en-US" sz="1300" dirty="0"/>
+          </a:p>
+          <a:p>
+            <a:pPr marL="342900" indent="-342900">
+              <a:spcAft>
+                <a:spcPts val="800"/>
+              </a:spcAft>
+              <a:buSzPct val="100000"/>
+              <a:buChar char="•"/>
+            </a:pPr>
+            <a:r>
+              <a:rPr lang="en-US" sz="1300" dirty="0">
+                <a:solidFill>
+                  <a:srgbClr val="CADCFC"/>
+                </a:solidFill>
+                <a:latin typeface="Calibri" pitchFamily="34" charset="0"/>
+                <a:ea typeface="Calibri" pitchFamily="34" charset="-122"/>
+                <a:cs typeface="Calibri" pitchFamily="34" charset="-120"/>
+              </a:rPr>
+              <a:t>Full progress write-up (PROGRESS.md)</a:t>
+            </a:r>
+            <a:endParaRPr lang="en-US" sz="1300" dirty="0"/>
+          </a:p>
+          <a:p>
+            <a:pPr marL="342900" indent="-342900">
+              <a:spcAft>
+                <a:spcPts val="800"/>
+              </a:spcAft>
+              <a:buSzPct val="100000"/>
+              <a:buChar char="•"/>
+            </a:pPr>
+            <a:r>
+              <a:rPr lang="en-US" sz="1300" dirty="0">
+                <a:solidFill>
+                  <a:srgbClr val="CADCFC"/>
+                </a:solidFill>
+                <a:latin typeface="Calibri" pitchFamily="34" charset="0"/>
+                <a:ea typeface="Calibri" pitchFamily="34" charset="-122"/>
+                <a:cs typeface="Calibri" pitchFamily="34" charset="-120"/>
+              </a:rPr>
+              <a:t>6,000-row training dataset included</a:t>
+            </a:r>
+            <a:endParaRPr lang="en-US" sz="1300" dirty="0"/>
+          </a:p>
+        </p:txBody>
+      </p:sp>
+      <p:sp>
+        <p:nvSpPr>
+          <p:cNvPr id="13" name="Text 1"/>
           <p:cNvSpPr/>
           <p:nvPr>
-            <p:ph idx="101" type="body" hasCustomPrompt="1"/>
+            <p:ph idx="102" type="body" hasCustomPrompt="1"/>
           </p:nvPr>
         </p:nvSpPr>
         <p:spPr>
           <a:xfrm>
-            <a:off x="731520" y="3977640"/>
-            <a:ext cx="9692640" cy="914400"/>
-          </a:xfrm>
-          <a:prstGeom prst="rect">
-            <a:avLst/>
-          </a:prstGeom>
-          <a:noFill/>
-          <a:ln/>
-        </p:spPr>
-        <p:txBody>
-          <a:bodyPr wrap="square" rtlCol="0" anchor="t"/>
-          <a:lstStyle/>
-          <a:p>
-            <a:pPr algn="l" indent="0" marL="0">
-              <a:buNone/>
-            </a:pPr>
-            <a:endParaRPr lang="en-US" sz="1600" dirty="0"/>
+            <a:off x="11521440" y="6473952"/>
+            <a:ext cx="548640" cy="274320"/>
+          </a:xfrm>
+          <a:prstGeom prst="rect">
+            <a:avLst/>
+          </a:prstGeom>
+          <a:noFill/>
+          <a:ln/>
+        </p:spPr>
+        <p:txBody>
+          <a:bodyPr wrap="square" rtlCol="0"/>
+          <a:lstStyle/>
+          <a:p>
+            <a:pPr algn="r" indent="0" marL="0">
+              <a:buNone/>
+            </a:pPr>
+            <a:endParaRPr lang="en-US" sz="1000" dirty="0"/>
+          </a:p>
+        </p:txBody>
+      </p:sp>
+      <p:sp>
+        <p:nvSpPr>
+          <p:cNvPr id="25" name="Slide Number Placeholder 0"/>
+          <p:cNvSpPr>
+            <a:spLocks noGrp="1"/>
+          </p:cNvSpPr>
+          <p:nvPr>
+            <p:ph type="sldNum" sz="quarter" idx="4294967295"/>
+          </p:nvPr>
+        </p:nvSpPr>
+        <p:spPr>
+          <a:xfrm>
+            <a:off x="11521440" y="6473952"/>
+            <a:ext cx="800000" cy="300000"/>
+          </a:xfrm>
+          <a:prstGeom prst="rect">
+            <a:avLst/>
+          </a:prstGeom>
+          <a:extLst>
+            <a:ext uri="{C572A759-6A51-4108-AA02-DFA0A04FC94B}">
+              <ma14:wrappingTextBoxFlag xmlns:ma14="http://schemas.microsoft.com/office/mac/drawingml/2011/main" val="0"/>
+            </a:ext>
+          </a:extLst>
+        </p:spPr>
+        <p:txBody>
+          <a:bodyPr/>
+          <a:lstStyle>
+            <a:lvl1pPr>
+              <a:defRPr sz="1000">
+                <a:solidFill>
+                  <a:srgbClr val="6B7280"/>
+                </a:solidFill>
+                <a:latin typeface="Calibri"/>
+                <a:ea typeface="Calibri"/>
+                <a:cs typeface="Calibri"/>
+              </a:defRPr>
+            </a:lvl1pPr>
+          </a:lstStyle>
+          <a:p>
+            <a:pPr algn="l"/>
+            <a:fld id="{F7021451-1387-4CA6-816F-3879F97B5CBC}" type="slidenum">
+              <a:rPr b="0" lang="en-US"/>
+              <a:t>9</a:t>
+            </a:fld>
+            <a:endParaRPr lang="en-US"/>
           </a:p>
         </p:txBody>
       </p:sp>

</xml_diff>